<commit_message>
fix(deck): keep 4.2 h on one line
Co-Authored-By: Claude Opus 5.5 <noreply@anthropic.com>
</commit_message>
<xml_diff>
--- a/deck/sovereign-health-exec-briefing.pptx
+++ b/deck/sovereign-health-exec-briefing.pptx
@@ -116,21 +116,21 @@
   <p:extLst>
     <p:ext uri="{521415D9-36F7-43E2-AB2F-B90AF26B5E84}">
       <p14:sectionLst xmlns:p14="http://schemas.microsoft.com/office/powerpoint/2010/main">
-        <p14:section name="What?" id="{42494655-6daf-caeb-6121-55cc289de711}">
+        <p14:section name="What?" id="{34a08415-720c-1da3-6a7a-71c9b63763d6}">
           <p14:sldIdLst>
             <p14:sldId id="256"/>
             <p14:sldId id="257"/>
             <p14:sldId id="258"/>
           </p14:sldIdLst>
         </p14:section>
-        <p14:section name="So What?" id="{c9abc35e-8143-1d8a-9ce6-a8cda954df05}">
+        <p14:section name="So What?" id="{ef091af4-0180-d190-f4aa-05b274c25a6e}">
           <p14:sldIdLst>
             <p14:sldId id="259"/>
             <p14:sldId id="260"/>
             <p14:sldId id="261"/>
           </p14:sldIdLst>
         </p14:section>
-        <p14:section name="Now What?" id="{d07d5c62-0cf8-9b71-050c-c807ff7ce830}">
+        <p14:section name="Now What?" id="{c2c73de6-3b14-6810-08a5-cf1bf8f6fbea}">
           <p14:sldIdLst>
             <p14:sldId id="262"/>
             <p14:sldId id="263"/>
@@ -3952,7 +3952,7 @@
                 <a:ea typeface="Calibri" pitchFamily="34" charset="-122"/>
                 <a:cs typeface="Calibri" pitchFamily="34" charset="-120"/>
               </a:rPr>
-              <a:t>Mean time-to-result today, up from 4.200A0h before the expansion</a:t>
+              <a:t>Mean time-to-result today, up from 4.2 h before the expansion</a:t>
             </a:r>
             <a:endParaRPr lang="en-US" sz="1400" dirty="0"/>
           </a:p>

</xml_diff>

<commit_message>
fix(design): drop side-border accent on bottleneck cards and buzzword copy
Co-Authored-By: Claude Opus 5.5 <noreply@anthropic.com>
</commit_message>
<xml_diff>
--- a/deck/sovereign-health-exec-briefing.pptx
+++ b/deck/sovereign-health-exec-briefing.pptx
@@ -116,21 +116,21 @@
   <p:extLst>
     <p:ext uri="{521415D9-36F7-43E2-AB2F-B90AF26B5E84}">
       <p14:sectionLst xmlns:p14="http://schemas.microsoft.com/office/powerpoint/2010/main">
-        <p14:section name="What?" id="{34a08415-720c-1da3-6a7a-71c9b63763d6}">
+        <p14:section name="What?" id="{769c6a10-c09d-1dd2-b541-9c4119b98085}">
           <p14:sldIdLst>
             <p14:sldId id="256"/>
             <p14:sldId id="257"/>
             <p14:sldId id="258"/>
           </p14:sldIdLst>
         </p14:section>
-        <p14:section name="So What?" id="{ef091af4-0180-d190-f4aa-05b274c25a6e}">
+        <p14:section name="So What?" id="{dc693a2e-3699-3596-376f-1061c8ac23b4}">
           <p14:sldIdLst>
             <p14:sldId id="259"/>
             <p14:sldId id="260"/>
             <p14:sldId id="261"/>
           </p14:sldIdLst>
         </p14:section>
-        <p14:section name="Now What?" id="{c2c73de6-3b14-6810-08a5-cf1bf8f6fbea}">
+        <p14:section name="Now What?" id="{e71763e6-a35e-ac3d-784c-b48ce7b20332}">
           <p14:sldIdLst>
             <p14:sldId id="262"/>
             <p14:sldId id="263"/>
@@ -1638,7 +1638,7 @@
           <a:p>
             <a:r>
               <a:rPr lang="en-US" dirty="0"/>
-              <a:t>Process cycle efficiency = value-added time / total cycle time. World-class healthcare processes exceed 15%.</a:t>
+              <a:t>Process cycle efficiency = value-added time / total cycle time. The healthcare benchmark is above 15%.</a:t>
             </a:r>
             <a:endParaRPr lang="en-US" dirty="0"/>
           </a:p>

</xml_diff>

<commit_message>
feat(deck): takeaway titles, plain subtitles and talking-point notes
Co-Authored-By: Claude Opus 5.5 <noreply@anthropic.com>
</commit_message>
<xml_diff>
--- a/deck/sovereign-health-exec-briefing.pptx
+++ b/deck/sovereign-health-exec-briefing.pptx
@@ -116,21 +116,21 @@
   <p:extLst>
     <p:ext uri="{521415D9-36F7-43E2-AB2F-B90AF26B5E84}">
       <p14:sectionLst xmlns:p14="http://schemas.microsoft.com/office/powerpoint/2010/main">
-        <p14:section name="What?" id="{769c6a10-c09d-1dd2-b541-9c4119b98085}">
+        <p14:section name="What?" id="{c4fd91df-e933-6f8d-a143-67aae04db7c8}">
           <p14:sldIdLst>
             <p14:sldId id="256"/>
             <p14:sldId id="257"/>
             <p14:sldId id="258"/>
           </p14:sldIdLst>
         </p14:section>
-        <p14:section name="So What?" id="{dc693a2e-3699-3596-376f-1061c8ac23b4}">
+        <p14:section name="So What?" id="{188a2480-1ac3-c65e-5a09-f1c9d87e632d}">
           <p14:sldIdLst>
             <p14:sldId id="259"/>
             <p14:sldId id="260"/>
             <p14:sldId id="261"/>
           </p14:sldIdLst>
         </p14:section>
-        <p14:section name="Now What?" id="{e71763e6-a35e-ac3d-784c-b48ce7b20332}">
+        <p14:section name="Now What?" id="{4d7e95ce-4cc6-54a3-5b56-6584a5b151b9}">
           <p14:sldIdLst>
             <p14:sldId id="262"/>
             <p14:sldId id="263"/>
@@ -1198,7 +1198,8 @@
           <a:p>
             <a:r>
               <a:rPr lang="en-US" dirty="0"/>
-              <a:t>Purpose: approve a $520K, 16-week program that cuts lab time-to-result by three quarters. Structure: what is happening, why it matters, what we do about it.</a:t>
+              <a:t>Talking point: Lab results now take 18.6 h on average, up from 4.2 h. This briefing shows where the time goes and asks for $520K to bring it down to 4.6 h.
+Detail: Structure: what is happening, why it matters, what we do about it.</a:t>
             </a:r>
             <a:endParaRPr lang="en-US" dirty="0"/>
           </a:p>
@@ -1286,7 +1287,8 @@
           <a:p>
             <a:r>
               <a:rPr lang="en-US" dirty="0"/>
-              <a:t>Ask: approve capital and name an executive sponsor for the central hub and ED deployment in weeks 11 to 13.</a:t>
+              <a:t>Talking point: We need two things today: approval for $520K and an executive sponsor. The first results arrive with the central hub and ED rollout in weeks 11 to 13.
+Detail: Ask: approve capital and name an executive sponsor for the central hub and ED deployment in weeks 11 to 13.</a:t>
             </a:r>
             <a:endParaRPr lang="en-US" dirty="0"/>
           </a:p>
@@ -1374,7 +1376,8 @@
           <a:p>
             <a:r>
               <a:rPr lang="en-US" dirty="0"/>
-              <a:t>The analyzer upgrade did its job. Everything around it did not scale: 96% of the cycle is queueing, transit, re-keying and exception handling.</a:t>
+              <a:t>Talking point: The analyzers work on each sample for 42 min. The other 17.9 h is spent waiting before and after.
+Detail: The analyzer upgrade did its job. Everything around it did not scale: 96% of the cycle is queueing, transit, re-keying and exception handling.</a:t>
             </a:r>
             <a:endParaRPr lang="en-US" dirty="0"/>
           </a:p>
@@ -1462,7 +1465,8 @@
           <a:p>
             <a:r>
               <a:rPr lang="en-US" dirty="0"/>
-              <a:t>Minutes come from timestamps mined across 10,000 orders. Testing shows queue time only; the 42-minute analyzer run is excluded.</a:t>
+              <a:t>Talking point: The biggest single wait is at sample intake, where tubes are logged in by hand. 60% of clinic samples arrive between 4 and 6 PM, just as evening staffing drops.
+Detail: Minutes come from timestamps mined across 10,000 orders. Testing shows queue time only; the 42-minute analyzer run is excluded.</a:t>
             </a:r>
             <a:endParaRPr lang="en-US" dirty="0"/>
           </a:p>
@@ -1550,7 +1554,8 @@
           <a:p>
             <a:r>
               <a:rPr lang="en-US" dirty="0"/>
-              <a:t>Each bottleneck maps to one lever on slide 8.</a:t>
+              <a:t>Talking point: Four problems cause most of the delay, and each has a fix later in the deck. One is that 38% of orders are marked urgent, so real emergencies get stuck behind routine work.
+Detail: Ranked by non-value-added minutes from the event log.</a:t>
             </a:r>
             <a:endParaRPr lang="en-US" dirty="0"/>
           </a:p>
@@ -1638,7 +1643,8 @@
           <a:p>
             <a:r>
               <a:rPr lang="en-US" dirty="0"/>
-              <a:t>Process cycle efficiency = value-added time / total cycle time. The healthcare benchmark is above 15%.</a:t>
+              <a:t>Talking point: For every hour a sample spends in the system, less than three minutes is real work. The rest is waiting, transport and fixing mistakes.
+Detail: Process cycle efficiency = value-added time / total cycle time. The healthcare benchmark is above 15%.</a:t>
             </a:r>
             <a:endParaRPr lang="en-US" dirty="0"/>
           </a:p>
@@ -1726,7 +1732,8 @@
           <a:p>
             <a:r>
               <a:rPr lang="en-US" dirty="0"/>
-              <a:t>Penalties and overtime are annual figures from finance. Patient risk shows up as ED length of stay and a 48-minute critical-value lag.</a:t>
+              <a:t>Talking point: The delay costs about $6M a year in penalties and overtime. Doctors also wait 48 min to hear about dangerous results.
+Detail: Penalties and overtime are annual figures from finance. Patient risk shows up as ED length of stay and a 48-minute critical-value lag.</a:t>
             </a:r>
             <a:endParaRPr lang="en-US" dirty="0"/>
           </a:p>
@@ -1814,7 +1821,8 @@
           <a:p>
             <a:r>
               <a:rPr lang="en-US" dirty="0"/>
-              <a:t>Steps fall from 18 to 12. Every remaining handoff is a scan or an API call.</a:t>
+              <a:t>Talking point: The new process removes six steps and every point where people retype data. Logging samples in drops from 4.5 h to 12 min.
+Detail: Steps fall from 18 to 12. Every remaining handoff is a scan or an API call.</a:t>
             </a:r>
             <a:endParaRPr lang="en-US" dirty="0"/>
           </a:p>
@@ -1902,7 +1910,8 @@
           <a:p>
             <a:r>
               <a:rPr lang="en-US" dirty="0"/>
-              <a:t>Before/after values for accessioning, clinic hold and exceptions are mined means from the simulated To-Be scenario.</a:t>
+              <a:t>Talking point: Each change targets one of the four problems from slide 4. The table shows the before and after for each one.
+Detail: Before/after values for accessioning, clinic hold and exceptions are mined means from the simulated To-Be scenario.</a:t>
             </a:r>
             <a:endParaRPr lang="en-US" dirty="0"/>
           </a:p>
@@ -1990,7 +1999,8 @@
           <a:p>
             <a:r>
               <a:rPr lang="en-US" dirty="0"/>
-              <a:t>ROI = (annual savings - capex) / capex. Savings categories: ED penalties $2.4M, overtime $850K, length of stay $680K, rework $420K.</a:t>
+              <a:t>Talking point: Results come back 75.3% faster and the program saves $4.35M a year. It pays for itself in 1.4 months.
+Detail: ROI = (annual savings - capex) / capex. Savings categories: ED penalties $2.4M, overtime $850K, length of stay $680K, rework $420K.</a:t>
             </a:r>
             <a:endParaRPr lang="en-US" dirty="0"/>
           </a:p>
@@ -2255,7 +2265,7 @@
         <p:spPr>
           <a:xfrm>
             <a:off x="548640" y="731520"/>
-            <a:ext cx="11064240" cy="822960"/>
+            <a:ext cx="11064240" cy="548640"/>
           </a:xfrm>
           <a:prstGeom prst="rect">
             <a:avLst/>
@@ -2268,7 +2278,7 @@
           <a:lstStyle>
             <a:lvl1pPr algn="l" indent="0" marL="0">
               <a:buNone/>
-              <a:defRPr lang="en-US" sz="3000" b="1" dirty="0">
+              <a:defRPr lang="en-US" sz="2800" b="1" dirty="0">
                 <a:solidFill>
                   <a:srgbClr val="0F1D30"/>
                 </a:solidFill>
@@ -2282,7 +2292,7 @@
             <a:pPr algn="l" indent="0" marL="0">
               <a:buNone/>
             </a:pPr>
-            <a:endParaRPr lang="en-US" sz="3000" dirty="0"/>
+            <a:endParaRPr lang="en-US" sz="2800" dirty="0"/>
           </a:p>
         </p:txBody>
       </p:sp>
@@ -2801,7 +2811,7 @@
                 <a:ea typeface="Cambria" pitchFamily="34" charset="-122"/>
                 <a:cs typeface="Cambria" pitchFamily="34" charset="-120"/>
               </a:rPr>
-              <a:t>Lab turnaround: 18.6 h to 4.6 h</a:t>
+              <a:t>Cutting lab result time from 18.6 h to 4.6 h</a:t>
             </a:r>
             <a:endParaRPr lang="en-US" sz="4000" dirty="0"/>
           </a:p>
@@ -2809,7 +2819,7 @@
       </p:sp>
       <p:sp>
         <p:nvSpPr>
-          <p:cNvPr id="4" name="Text 2"/>
+          <p:cNvPr id="4" name="subtitle"/>
           <p:cNvSpPr txBox="1"/>
           <p:nvPr/>
         </p:nvSpPr>
@@ -2840,7 +2850,7 @@
                 <a:ea typeface="Calibri" pitchFamily="34" charset="-122"/>
                 <a:cs typeface="Calibri" pitchFamily="34" charset="-120"/>
               </a:rPr>
-              <a:t>Process mapping, value stream analysis and a 16-week plan to remove the queues around a $6.5M analyzer investment</a:t>
+              <a:t>The fix uses the same analyzers and staff. It changes how samples and information move between teams.</a:t>
             </a:r>
             <a:endParaRPr lang="en-US" sz="2000" dirty="0"/>
           </a:p>
@@ -2994,7 +3004,46 @@
       </p:sp>
       <p:sp>
         <p:nvSpPr>
-          <p:cNvPr id="5" name="Text 2"/>
+          <p:cNvPr id="4" name="subtitle"/>
+          <p:cNvSpPr txBox="1"/>
+          <p:nvPr/>
+        </p:nvSpPr>
+        <p:spPr>
+          <a:xfrm>
+            <a:off x="731520" y="2148840"/>
+            <a:ext cx="10698480" cy="457200"/>
+          </a:xfrm>
+          <a:prstGeom prst="rect">
+            <a:avLst/>
+          </a:prstGeom>
+          <a:noFill/>
+          <a:ln/>
+        </p:spPr>
+        <p:txBody>
+          <a:bodyPr wrap="square" lIns="0" tIns="0" rIns="0" bIns="0" rtlCol="0" anchor="ctr"/>
+          <a:lstStyle/>
+          <a:p>
+            <a:pPr indent="0" marL="0">
+              <a:buNone/>
+            </a:pPr>
+            <a:r>
+              <a:rPr lang="en-US" sz="1800" dirty="0">
+                <a:solidFill>
+                  <a:srgbClr val="CADCFC"/>
+                </a:solidFill>
+                <a:latin typeface="Calibri" pitchFamily="34" charset="0"/>
+                <a:ea typeface="Calibri" pitchFamily="34" charset="-122"/>
+                <a:cs typeface="Calibri" pitchFamily="34" charset="-120"/>
+              </a:rPr>
+              <a:t>Starting needs two things: the capital and a named executive sponsor.</a:t>
+            </a:r>
+            <a:endParaRPr lang="en-US" sz="1800" dirty="0"/>
+          </a:p>
+        </p:txBody>
+      </p:sp>
+      <p:sp>
+        <p:nvSpPr>
+          <p:cNvPr id="6" name="Text 3"/>
           <p:cNvSpPr txBox="1"/>
           <p:nvPr/>
         </p:nvSpPr>
@@ -3033,7 +3082,7 @@
       </p:sp>
       <p:sp>
         <p:nvSpPr>
-          <p:cNvPr id="6" name="Shape 3"/>
+          <p:cNvPr id="7" name="Shape 4"/>
           <p:cNvSpPr/>
           <p:nvPr/>
         </p:nvSpPr>
@@ -3058,7 +3107,7 @@
       </p:sp>
       <p:sp>
         <p:nvSpPr>
-          <p:cNvPr id="7" name="phase-1"/>
+          <p:cNvPr id="8" name="phase-1"/>
           <p:cNvSpPr/>
           <p:nvPr/>
         </p:nvSpPr>
@@ -3085,7 +3134,7 @@
       </p:sp>
       <p:sp>
         <p:nvSpPr>
-          <p:cNvPr id="8" name="Text 5"/>
+          <p:cNvPr id="9" name="Text 6"/>
           <p:cNvSpPr txBox="1"/>
           <p:nvPr/>
         </p:nvSpPr>
@@ -3124,7 +3173,7 @@
       </p:sp>
       <p:sp>
         <p:nvSpPr>
-          <p:cNvPr id="9" name="Shape 6"/>
+          <p:cNvPr id="10" name="Shape 7"/>
           <p:cNvSpPr/>
           <p:nvPr/>
         </p:nvSpPr>
@@ -3149,7 +3198,7 @@
       </p:sp>
       <p:sp>
         <p:nvSpPr>
-          <p:cNvPr id="10" name="phase-2"/>
+          <p:cNvPr id="11" name="phase-2"/>
           <p:cNvSpPr/>
           <p:nvPr/>
         </p:nvSpPr>
@@ -3176,7 +3225,7 @@
       </p:sp>
       <p:sp>
         <p:nvSpPr>
-          <p:cNvPr id="11" name="Text 8"/>
+          <p:cNvPr id="12" name="Text 9"/>
           <p:cNvSpPr txBox="1"/>
           <p:nvPr/>
         </p:nvSpPr>
@@ -3215,7 +3264,7 @@
       </p:sp>
       <p:sp>
         <p:nvSpPr>
-          <p:cNvPr id="12" name="Shape 9"/>
+          <p:cNvPr id="13" name="Shape 10"/>
           <p:cNvSpPr/>
           <p:nvPr/>
         </p:nvSpPr>
@@ -3240,7 +3289,7 @@
       </p:sp>
       <p:sp>
         <p:nvSpPr>
-          <p:cNvPr id="13" name="phase-3"/>
+          <p:cNvPr id="14" name="phase-3"/>
           <p:cNvSpPr/>
           <p:nvPr/>
         </p:nvSpPr>
@@ -3267,7 +3316,7 @@
       </p:sp>
       <p:sp>
         <p:nvSpPr>
-          <p:cNvPr id="14" name="Text 11"/>
+          <p:cNvPr id="15" name="Text 12"/>
           <p:cNvSpPr txBox="1"/>
           <p:nvPr/>
         </p:nvSpPr>
@@ -3306,7 +3355,7 @@
       </p:sp>
       <p:sp>
         <p:nvSpPr>
-          <p:cNvPr id="15" name="Shape 12"/>
+          <p:cNvPr id="16" name="Shape 13"/>
           <p:cNvSpPr/>
           <p:nvPr/>
         </p:nvSpPr>
@@ -3331,7 +3380,7 @@
       </p:sp>
       <p:sp>
         <p:nvSpPr>
-          <p:cNvPr id="16" name="phase-4"/>
+          <p:cNvPr id="17" name="phase-4"/>
           <p:cNvSpPr/>
           <p:nvPr/>
         </p:nvSpPr>
@@ -3358,7 +3407,7 @@
       </p:sp>
       <p:sp>
         <p:nvSpPr>
-          <p:cNvPr id="17" name="Text 14"/>
+          <p:cNvPr id="18" name="Text 15"/>
           <p:cNvSpPr txBox="1"/>
           <p:nvPr/>
         </p:nvSpPr>
@@ -3397,7 +3446,7 @@
       </p:sp>
       <p:sp>
         <p:nvSpPr>
-          <p:cNvPr id="18" name="Shape 15"/>
+          <p:cNvPr id="19" name="Shape 16"/>
           <p:cNvSpPr/>
           <p:nvPr/>
         </p:nvSpPr>
@@ -3422,7 +3471,7 @@
       </p:sp>
       <p:sp>
         <p:nvSpPr>
-          <p:cNvPr id="19" name="phase-5"/>
+          <p:cNvPr id="20" name="phase-5"/>
           <p:cNvSpPr/>
           <p:nvPr/>
         </p:nvSpPr>
@@ -3449,7 +3498,7 @@
       </p:sp>
       <p:sp>
         <p:nvSpPr>
-          <p:cNvPr id="20" name="Text 17"/>
+          <p:cNvPr id="21" name="Text 18"/>
           <p:cNvSpPr txBox="1"/>
           <p:nvPr/>
         </p:nvSpPr>
@@ -3488,7 +3537,7 @@
       </p:sp>
       <p:sp>
         <p:nvSpPr>
-          <p:cNvPr id="21" name="Shape 18"/>
+          <p:cNvPr id="22" name="Shape 19"/>
           <p:cNvSpPr/>
           <p:nvPr/>
         </p:nvSpPr>
@@ -3513,7 +3562,7 @@
       </p:sp>
       <p:sp>
         <p:nvSpPr>
-          <p:cNvPr id="22" name="phase-6"/>
+          <p:cNvPr id="23" name="phase-6"/>
           <p:cNvSpPr/>
           <p:nvPr/>
         </p:nvSpPr>
@@ -3540,7 +3589,7 @@
       </p:sp>
       <p:sp>
         <p:nvSpPr>
-          <p:cNvPr id="23" name="Text 20"/>
+          <p:cNvPr id="24" name="Text 21"/>
           <p:cNvSpPr txBox="1"/>
           <p:nvPr/>
         </p:nvSpPr>
@@ -3579,7 +3628,7 @@
       </p:sp>
       <p:sp>
         <p:nvSpPr>
-          <p:cNvPr id="24" name="Shape 21"/>
+          <p:cNvPr id="25" name="Shape 22"/>
           <p:cNvSpPr/>
           <p:nvPr/>
         </p:nvSpPr>
@@ -3604,7 +3653,7 @@
       </p:sp>
       <p:sp>
         <p:nvSpPr>
-          <p:cNvPr id="25" name="phase-7"/>
+          <p:cNvPr id="26" name="phase-7"/>
           <p:cNvSpPr/>
           <p:nvPr/>
         </p:nvSpPr>
@@ -3631,7 +3680,7 @@
       </p:sp>
       <p:sp>
         <p:nvSpPr>
-          <p:cNvPr id="26" name="Text 23"/>
+          <p:cNvPr id="27" name="Text 24"/>
           <p:cNvSpPr txBox="1"/>
           <p:nvPr/>
         </p:nvSpPr>
@@ -3670,7 +3719,7 @@
       </p:sp>
       <p:sp>
         <p:nvSpPr>
-          <p:cNvPr id="27" name="Text 24"/>
+          <p:cNvPr id="28" name="Text 25"/>
           <p:cNvSpPr txBox="1"/>
           <p:nvPr/>
         </p:nvSpPr>
@@ -3709,7 +3758,7 @@
       </p:sp>
       <p:sp>
         <p:nvSpPr>
-          <p:cNvPr id="28" name="Text 25"/>
+          <p:cNvPr id="29" name="Text 26"/>
           <p:cNvSpPr txBox="1"/>
           <p:nvPr/>
         </p:nvSpPr>
@@ -3823,7 +3872,7 @@
         <p:spPr>
           <a:xfrm>
             <a:off x="548640" y="731520"/>
-            <a:ext cx="11064240" cy="822960"/>
+            <a:ext cx="11064240" cy="548640"/>
           </a:xfrm>
           <a:prstGeom prst="rect">
             <a:avLst/>
@@ -3839,7 +3888,7 @@
               <a:buNone/>
             </a:pPr>
             <a:r>
-              <a:rPr lang="en-US" sz="3000" b="1" dirty="0">
+              <a:rPr lang="en-US" sz="2800" b="1" dirty="0">
                 <a:solidFill>
                   <a:srgbClr val="0F1D30"/>
                 </a:solidFill>
@@ -3849,13 +3898,52 @@
               </a:rPr>
               <a:t>Testing takes 42 minutes of an 18.6 h wait</a:t>
             </a:r>
-            <a:endParaRPr lang="en-US" sz="3000" dirty="0"/>
-          </a:p>
-        </p:txBody>
-      </p:sp>
-      <p:sp>
-        <p:nvSpPr>
-          <p:cNvPr id="5" name="stat-card-1"/>
+            <a:endParaRPr lang="en-US" sz="2800" dirty="0"/>
+          </a:p>
+        </p:txBody>
+      </p:sp>
+      <p:sp>
+        <p:nvSpPr>
+          <p:cNvPr id="4" name="subtitle"/>
+          <p:cNvSpPr txBox="1"/>
+          <p:nvPr/>
+        </p:nvSpPr>
+        <p:spPr>
+          <a:xfrm>
+            <a:off x="548640" y="1298448"/>
+            <a:ext cx="11064240" cy="365760"/>
+          </a:xfrm>
+          <a:prstGeom prst="rect">
+            <a:avLst/>
+          </a:prstGeom>
+          <a:noFill/>
+          <a:ln/>
+        </p:spPr>
+        <p:txBody>
+          <a:bodyPr wrap="square" lIns="0" tIns="0" rIns="0" bIns="0" rtlCol="0" anchor="ctr"/>
+          <a:lstStyle/>
+          <a:p>
+            <a:pPr indent="0" marL="0">
+              <a:buNone/>
+            </a:pPr>
+            <a:r>
+              <a:rPr lang="en-US" sz="1600" dirty="0">
+                <a:solidFill>
+                  <a:srgbClr val="5F6672"/>
+                </a:solidFill>
+                <a:latin typeface="Calibri" pitchFamily="34" charset="0"/>
+                <a:ea typeface="Calibri" pitchFamily="34" charset="-122"/>
+                <a:cs typeface="Calibri" pitchFamily="34" charset="-120"/>
+              </a:rPr>
+              <a:t>The new analyzers work. Samples spend the rest of the day waiting around them.</a:t>
+            </a:r>
+            <a:endParaRPr lang="en-US" sz="1600" dirty="0"/>
+          </a:p>
+        </p:txBody>
+      </p:sp>
+      <p:sp>
+        <p:nvSpPr>
+          <p:cNvPr id="6" name="stat-card-1"/>
           <p:cNvSpPr/>
           <p:nvPr/>
         </p:nvSpPr>
@@ -3882,7 +3970,7 @@
       </p:sp>
       <p:sp>
         <p:nvSpPr>
-          <p:cNvPr id="6" name="Text 3"/>
+          <p:cNvPr id="7" name="Text 4"/>
           <p:cNvSpPr txBox="1"/>
           <p:nvPr/>
         </p:nvSpPr>
@@ -3921,7 +4009,7 @@
       </p:sp>
       <p:sp>
         <p:nvSpPr>
-          <p:cNvPr id="7" name="Text 4"/>
+          <p:cNvPr id="8" name="Text 5"/>
           <p:cNvSpPr txBox="1"/>
           <p:nvPr/>
         </p:nvSpPr>
@@ -3960,7 +4048,7 @@
       </p:sp>
       <p:sp>
         <p:nvSpPr>
-          <p:cNvPr id="8" name="stat-card-2"/>
+          <p:cNvPr id="9" name="stat-card-2"/>
           <p:cNvSpPr/>
           <p:nvPr/>
         </p:nvSpPr>
@@ -3987,7 +4075,7 @@
       </p:sp>
       <p:sp>
         <p:nvSpPr>
-          <p:cNvPr id="9" name="Text 6"/>
+          <p:cNvPr id="10" name="Text 7"/>
           <p:cNvSpPr txBox="1"/>
           <p:nvPr/>
         </p:nvSpPr>
@@ -4026,7 +4114,7 @@
       </p:sp>
       <p:sp>
         <p:nvSpPr>
-          <p:cNvPr id="10" name="Text 7"/>
+          <p:cNvPr id="11" name="Text 8"/>
           <p:cNvSpPr txBox="1"/>
           <p:nvPr/>
         </p:nvSpPr>
@@ -4065,7 +4153,7 @@
       </p:sp>
       <p:sp>
         <p:nvSpPr>
-          <p:cNvPr id="11" name="stat-card-3"/>
+          <p:cNvPr id="12" name="stat-card-3"/>
           <p:cNvSpPr/>
           <p:nvPr/>
         </p:nvSpPr>
@@ -4092,7 +4180,7 @@
       </p:sp>
       <p:sp>
         <p:nvSpPr>
-          <p:cNvPr id="12" name="Text 9"/>
+          <p:cNvPr id="13" name="Text 10"/>
           <p:cNvSpPr txBox="1"/>
           <p:nvPr/>
         </p:nvSpPr>
@@ -4131,7 +4219,7 @@
       </p:sp>
       <p:sp>
         <p:nvSpPr>
-          <p:cNvPr id="13" name="Text 10"/>
+          <p:cNvPr id="14" name="Text 11"/>
           <p:cNvSpPr txBox="1"/>
           <p:nvPr/>
         </p:nvSpPr>
@@ -4170,7 +4258,7 @@
       </p:sp>
       <p:sp>
         <p:nvSpPr>
-          <p:cNvPr id="14" name="Text 11"/>
+          <p:cNvPr id="15" name="Text 12"/>
           <p:cNvSpPr txBox="1"/>
           <p:nvPr/>
         </p:nvSpPr>
@@ -4346,7 +4434,7 @@
         <p:spPr>
           <a:xfrm>
             <a:off x="548640" y="731520"/>
-            <a:ext cx="11064240" cy="822960"/>
+            <a:ext cx="11064240" cy="548640"/>
           </a:xfrm>
           <a:prstGeom prst="rect">
             <a:avLst/>
@@ -4362,7 +4450,7 @@
               <a:buNone/>
             </a:pPr>
             <a:r>
-              <a:rPr lang="en-US" sz="3000" b="1" dirty="0">
+              <a:rPr lang="en-US" sz="2800" b="1" dirty="0">
                 <a:solidFill>
                   <a:srgbClr val="0F1D30"/>
                 </a:solidFill>
@@ -4370,15 +4458,54 @@
                 <a:ea typeface="Cambria" pitchFamily="34" charset="-122"/>
                 <a:cs typeface="Cambria" pitchFamily="34" charset="-120"/>
               </a:rPr>
-              <a:t>Central accessioning holds 25% of all waiting time</a:t>
-            </a:r>
-            <a:endParaRPr lang="en-US" sz="3000" dirty="0"/>
+              <a:t>Sample intake holds 25% of all waiting time</a:t>
+            </a:r>
+            <a:endParaRPr lang="en-US" sz="2800" dirty="0"/>
+          </a:p>
+        </p:txBody>
+      </p:sp>
+      <p:sp>
+        <p:nvSpPr>
+          <p:cNvPr id="4" name="subtitle"/>
+          <p:cNvSpPr txBox="1"/>
+          <p:nvPr/>
+        </p:nvSpPr>
+        <p:spPr>
+          <a:xfrm>
+            <a:off x="548640" y="1298448"/>
+            <a:ext cx="11064240" cy="365760"/>
+          </a:xfrm>
+          <a:prstGeom prst="rect">
+            <a:avLst/>
+          </a:prstGeom>
+          <a:noFill/>
+          <a:ln/>
+        </p:spPr>
+        <p:txBody>
+          <a:bodyPr wrap="square" lIns="0" tIns="0" rIns="0" bIns="0" rtlCol="0" anchor="ctr"/>
+          <a:lstStyle/>
+          <a:p>
+            <a:pPr indent="0" marL="0">
+              <a:buNone/>
+            </a:pPr>
+            <a:r>
+              <a:rPr lang="en-US" sz="1600" dirty="0">
+                <a:solidFill>
+                  <a:srgbClr val="5F6672"/>
+                </a:solidFill>
+                <a:latin typeface="Calibri" pitchFamily="34" charset="0"/>
+                <a:ea typeface="Calibri" pitchFamily="34" charset="-122"/>
+                <a:cs typeface="Calibri" pitchFamily="34" charset="-120"/>
+              </a:rPr>
+              <a:t>Logging samples in when they arrive is the biggest single queue.</a:t>
+            </a:r>
+            <a:endParaRPr lang="en-US" sz="1600" dirty="0"/>
           </a:p>
         </p:txBody>
       </p:sp>
       <p:graphicFrame>
         <p:nvGraphicFramePr>
-          <p:cNvPr id="5" name="Chart 0" descr=""/>
+          <p:cNvPr id="6" name="Chart 0" descr=""/>
           <p:cNvGraphicFramePr/>
           <p:nvPr/>
         </p:nvGraphicFramePr>
@@ -4394,7 +4521,7 @@
       </p:graphicFrame>
       <p:sp>
         <p:nvSpPr>
-          <p:cNvPr id="6" name="commentary"/>
+          <p:cNvPr id="7" name="commentary"/>
           <p:cNvSpPr/>
           <p:nvPr/>
         </p:nvSpPr>
@@ -4421,7 +4548,7 @@
       </p:sp>
       <p:sp>
         <p:nvSpPr>
-          <p:cNvPr id="7" name="Text 3"/>
+          <p:cNvPr id="8" name="Text 4"/>
           <p:cNvSpPr txBox="1"/>
           <p:nvPr/>
         </p:nvSpPr>
@@ -4629,7 +4756,7 @@
         <p:spPr>
           <a:xfrm>
             <a:off x="548640" y="731520"/>
-            <a:ext cx="11064240" cy="822960"/>
+            <a:ext cx="11064240" cy="548640"/>
           </a:xfrm>
           <a:prstGeom prst="rect">
             <a:avLst/>
@@ -4645,7 +4772,7 @@
               <a:buNone/>
             </a:pPr>
             <a:r>
-              <a:rPr lang="en-US" sz="3000" b="1" dirty="0">
+              <a:rPr lang="en-US" sz="2800" b="1" dirty="0">
                 <a:solidFill>
                   <a:srgbClr val="0F1D30"/>
                 </a:solidFill>
@@ -4653,15 +4780,54 @@
                 <a:ea typeface="Cambria" pitchFamily="34" charset="-122"/>
                 <a:cs typeface="Cambria" pitchFamily="34" charset="-120"/>
               </a:rPr>
-              <a:t>Four bottlenecks drive the delay</a:t>
-            </a:r>
-            <a:endParaRPr lang="en-US" sz="3000" dirty="0"/>
-          </a:p>
-        </p:txBody>
-      </p:sp>
-      <p:sp>
-        <p:nvSpPr>
-          <p:cNvPr id="5" name="bottleneck-1"/>
+              <a:t>Four problems cause most of the delay</a:t>
+            </a:r>
+            <a:endParaRPr lang="en-US" sz="2800" dirty="0"/>
+          </a:p>
+        </p:txBody>
+      </p:sp>
+      <p:sp>
+        <p:nvSpPr>
+          <p:cNvPr id="4" name="subtitle"/>
+          <p:cNvSpPr txBox="1"/>
+          <p:nvPr/>
+        </p:nvSpPr>
+        <p:spPr>
+          <a:xfrm>
+            <a:off x="548640" y="1298448"/>
+            <a:ext cx="11064240" cy="365760"/>
+          </a:xfrm>
+          <a:prstGeom prst="rect">
+            <a:avLst/>
+          </a:prstGeom>
+          <a:noFill/>
+          <a:ln/>
+        </p:spPr>
+        <p:txBody>
+          <a:bodyPr wrap="square" lIns="0" tIns="0" rIns="0" bIns="0" rtlCol="0" anchor="ctr"/>
+          <a:lstStyle/>
+          <a:p>
+            <a:pPr indent="0" marL="0">
+              <a:buNone/>
+            </a:pPr>
+            <a:r>
+              <a:rPr lang="en-US" sz="1600" dirty="0">
+                <a:solidFill>
+                  <a:srgbClr val="5F6672"/>
+                </a:solidFill>
+                <a:latin typeface="Calibri" pitchFamily="34" charset="0"/>
+                <a:ea typeface="Calibri" pitchFamily="34" charset="-122"/>
+                <a:cs typeface="Calibri" pitchFamily="34" charset="-120"/>
+              </a:rPr>
+              <a:t>Each problem has a matching fix on slide 8.</a:t>
+            </a:r>
+            <a:endParaRPr lang="en-US" sz="1600" dirty="0"/>
+          </a:p>
+        </p:txBody>
+      </p:sp>
+      <p:sp>
+        <p:nvSpPr>
+          <p:cNvPr id="6" name="bottleneck-1"/>
           <p:cNvSpPr/>
           <p:nvPr/>
         </p:nvSpPr>
@@ -4688,7 +4854,7 @@
       </p:sp>
       <p:sp>
         <p:nvSpPr>
-          <p:cNvPr id="6" name="Text 3"/>
+          <p:cNvPr id="7" name="Text 4"/>
           <p:cNvSpPr txBox="1"/>
           <p:nvPr/>
         </p:nvSpPr>
@@ -4727,7 +4893,7 @@
       </p:sp>
       <p:sp>
         <p:nvSpPr>
-          <p:cNvPr id="7" name="Text 4"/>
+          <p:cNvPr id="8" name="Text 5"/>
           <p:cNvSpPr txBox="1"/>
           <p:nvPr/>
         </p:nvSpPr>
@@ -4766,7 +4932,7 @@
       </p:sp>
       <p:sp>
         <p:nvSpPr>
-          <p:cNvPr id="8" name="Text 5"/>
+          <p:cNvPr id="9" name="Text 6"/>
           <p:cNvSpPr txBox="1"/>
           <p:nvPr/>
         </p:nvSpPr>
@@ -4805,7 +4971,7 @@
       </p:sp>
       <p:sp>
         <p:nvSpPr>
-          <p:cNvPr id="9" name="bottleneck-2"/>
+          <p:cNvPr id="10" name="bottleneck-2"/>
           <p:cNvSpPr/>
           <p:nvPr/>
         </p:nvSpPr>
@@ -4832,7 +4998,7 @@
       </p:sp>
       <p:sp>
         <p:nvSpPr>
-          <p:cNvPr id="10" name="Text 7"/>
+          <p:cNvPr id="11" name="Text 8"/>
           <p:cNvSpPr txBox="1"/>
           <p:nvPr/>
         </p:nvSpPr>
@@ -4871,7 +5037,7 @@
       </p:sp>
       <p:sp>
         <p:nvSpPr>
-          <p:cNvPr id="11" name="Text 8"/>
+          <p:cNvPr id="12" name="Text 9"/>
           <p:cNvSpPr txBox="1"/>
           <p:nvPr/>
         </p:nvSpPr>
@@ -4910,7 +5076,7 @@
       </p:sp>
       <p:sp>
         <p:nvSpPr>
-          <p:cNvPr id="12" name="Text 9"/>
+          <p:cNvPr id="13" name="Text 10"/>
           <p:cNvSpPr txBox="1"/>
           <p:nvPr/>
         </p:nvSpPr>
@@ -4949,7 +5115,7 @@
       </p:sp>
       <p:sp>
         <p:nvSpPr>
-          <p:cNvPr id="13" name="bottleneck-3"/>
+          <p:cNvPr id="14" name="bottleneck-3"/>
           <p:cNvSpPr/>
           <p:nvPr/>
         </p:nvSpPr>
@@ -4976,7 +5142,7 @@
       </p:sp>
       <p:sp>
         <p:nvSpPr>
-          <p:cNvPr id="14" name="Text 11"/>
+          <p:cNvPr id="15" name="Text 12"/>
           <p:cNvSpPr txBox="1"/>
           <p:nvPr/>
         </p:nvSpPr>
@@ -5015,7 +5181,7 @@
       </p:sp>
       <p:sp>
         <p:nvSpPr>
-          <p:cNvPr id="15" name="Text 12"/>
+          <p:cNvPr id="16" name="Text 13"/>
           <p:cNvSpPr txBox="1"/>
           <p:nvPr/>
         </p:nvSpPr>
@@ -5054,7 +5220,7 @@
       </p:sp>
       <p:sp>
         <p:nvSpPr>
-          <p:cNvPr id="16" name="Text 13"/>
+          <p:cNvPr id="17" name="Text 14"/>
           <p:cNvSpPr txBox="1"/>
           <p:nvPr/>
         </p:nvSpPr>
@@ -5093,7 +5259,7 @@
       </p:sp>
       <p:sp>
         <p:nvSpPr>
-          <p:cNvPr id="17" name="bottleneck-4"/>
+          <p:cNvPr id="18" name="bottleneck-4"/>
           <p:cNvSpPr/>
           <p:nvPr/>
         </p:nvSpPr>
@@ -5120,7 +5286,7 @@
       </p:sp>
       <p:sp>
         <p:nvSpPr>
-          <p:cNvPr id="18" name="Text 15"/>
+          <p:cNvPr id="19" name="Text 16"/>
           <p:cNvSpPr txBox="1"/>
           <p:nvPr/>
         </p:nvSpPr>
@@ -5159,7 +5325,7 @@
       </p:sp>
       <p:sp>
         <p:nvSpPr>
-          <p:cNvPr id="19" name="Text 16"/>
+          <p:cNvPr id="20" name="Text 17"/>
           <p:cNvSpPr txBox="1"/>
           <p:nvPr/>
         </p:nvSpPr>
@@ -5198,7 +5364,7 @@
       </p:sp>
       <p:sp>
         <p:nvSpPr>
-          <p:cNvPr id="20" name="Text 17"/>
+          <p:cNvPr id="21" name="Text 18"/>
           <p:cNvSpPr txBox="1"/>
           <p:nvPr/>
         </p:nvSpPr>
@@ -5360,7 +5526,7 @@
         <p:spPr>
           <a:xfrm>
             <a:off x="548640" y="731520"/>
-            <a:ext cx="11064240" cy="822960"/>
+            <a:ext cx="11064240" cy="548640"/>
           </a:xfrm>
           <a:prstGeom prst="rect">
             <a:avLst/>
@@ -5376,7 +5542,7 @@
               <a:buNone/>
             </a:pPr>
             <a:r>
-              <a:rPr lang="en-US" sz="3000" b="1" dirty="0">
+              <a:rPr lang="en-US" sz="2800" b="1" dirty="0">
                 <a:solidFill>
                   <a:srgbClr val="0F1D30"/>
                 </a:solidFill>
@@ -5384,42 +5550,65 @@
                 <a:ea typeface="Cambria" pitchFamily="34" charset="-122"/>
                 <a:cs typeface="Cambria" pitchFamily="34" charset="-120"/>
               </a:rPr>
-              <a:t>Only 3.76% of the cycle adds value</a:t>
-            </a:r>
-            <a:endParaRPr lang="en-US" sz="3000" dirty="0"/>
-          </a:p>
-        </p:txBody>
-      </p:sp>
-      <p:graphicFrame>
-        <p:nvGraphicFramePr>
-          <p:cNvPr id="5" name="Chart 0" descr=""/>
-          <p:cNvGraphicFramePr/>
-          <p:nvPr/>
-        </p:nvGraphicFramePr>
-        <p:xfrm>
-          <a:off x="548640" y="1737360"/>
-          <a:ext cx="7315200" cy="4206240"/>
-        </p:xfrm>
-        <a:graphic xmlns:a="http://schemas.openxmlformats.org/drawingml/2006/main">
-          <a:graphicData uri="http://schemas.openxmlformats.org/drawingml/2006/chart">
-            <c:chart xmlns:c="http://schemas.openxmlformats.org/drawingml/2006/chart" r:id="rId1"/>
-          </a:graphicData>
-        </a:graphic>
-      </p:graphicFrame>
-      <p:sp>
-        <p:nvSpPr>
-          <p:cNvPr id="6" name="pce-callout"/>
+              <a:t>Only 4% of the 18.6 h is real work</a:t>
+            </a:r>
+            <a:endParaRPr lang="en-US" sz="2800" dirty="0"/>
+          </a:p>
+        </p:txBody>
+      </p:sp>
+      <p:sp>
+        <p:nvSpPr>
+          <p:cNvPr id="4" name="subtitle"/>
+          <p:cNvSpPr txBox="1"/>
+          <p:nvPr/>
+        </p:nvSpPr>
+        <p:spPr>
+          <a:xfrm>
+            <a:off x="548640" y="1298448"/>
+            <a:ext cx="11064240" cy="365760"/>
+          </a:xfrm>
+          <a:prstGeom prst="rect">
+            <a:avLst/>
+          </a:prstGeom>
+          <a:noFill/>
+          <a:ln/>
+        </p:spPr>
+        <p:txBody>
+          <a:bodyPr wrap="square" lIns="0" tIns="0" rIns="0" bIns="0" rtlCol="0" anchor="ctr"/>
+          <a:lstStyle/>
+          <a:p>
+            <a:pPr indent="0" marL="0">
+              <a:buNone/>
+            </a:pPr>
+            <a:r>
+              <a:rPr lang="en-US" sz="1600" dirty="0">
+                <a:solidFill>
+                  <a:srgbClr val="5F6672"/>
+                </a:solidFill>
+                <a:latin typeface="Calibri" pitchFamily="34" charset="0"/>
+                <a:ea typeface="Calibri" pitchFamily="34" charset="-122"/>
+                <a:cs typeface="Calibri" pitchFamily="34" charset="-120"/>
+              </a:rPr>
+              <a:t>The rest is samples waiting in queues between teams.</a:t>
+            </a:r>
+            <a:endParaRPr lang="en-US" sz="1600" dirty="0"/>
+          </a:p>
+        </p:txBody>
+      </p:sp>
+      <p:sp>
+        <p:nvSpPr>
+          <p:cNvPr id="6" name="waiting-share"/>
           <p:cNvSpPr/>
           <p:nvPr/>
         </p:nvSpPr>
         <p:spPr>
           <a:xfrm>
-            <a:off x="8229600" y="1737360"/>
-            <a:ext cx="3383280" cy="4206240"/>
+            <a:off x="548640" y="1783080"/>
+            <a:ext cx="3840480" cy="4206240"/>
           </a:xfrm>
           <a:prstGeom prst="roundRect">
             <a:avLst>
-              <a:gd name="adj" fmla="val 2162"/>
+              <a:gd name="adj" fmla="val 1905"/>
             </a:avLst>
           </a:prstGeom>
           <a:solidFill>
@@ -5435,14 +5624,14 @@
       </p:sp>
       <p:sp>
         <p:nvSpPr>
-          <p:cNvPr id="7" name="Text 3"/>
+          <p:cNvPr id="7" name="Text 4"/>
           <p:cNvSpPr txBox="1"/>
           <p:nvPr/>
         </p:nvSpPr>
         <p:spPr>
           <a:xfrm>
-            <a:off x="8503920" y="2011680"/>
-            <a:ext cx="2834640" cy="822960"/>
+            <a:off x="822960" y="2011680"/>
+            <a:ext cx="3291840" cy="1188720"/>
           </a:xfrm>
           <a:prstGeom prst="rect">
             <a:avLst/>
@@ -5458,7 +5647,7 @@
               <a:buNone/>
             </a:pPr>
             <a:r>
-              <a:rPr lang="en-US" sz="4000" b="1" dirty="0">
+              <a:rPr lang="en-US" sz="7200" b="1" dirty="0">
                 <a:solidFill>
                   <a:srgbClr val="EB6834"/>
                 </a:solidFill>
@@ -5466,22 +5655,22 @@
                 <a:ea typeface="Cambria" pitchFamily="34" charset="-122"/>
                 <a:cs typeface="Cambria" pitchFamily="34" charset="-120"/>
               </a:rPr>
-              <a:t>3.76%</a:t>
-            </a:r>
-            <a:endParaRPr lang="en-US" sz="4000" dirty="0"/>
-          </a:p>
-        </p:txBody>
-      </p:sp>
-      <p:sp>
-        <p:nvSpPr>
-          <p:cNvPr id="8" name="Text 4"/>
+              <a:t>96%</a:t>
+            </a:r>
+            <a:endParaRPr lang="en-US" sz="7200" dirty="0"/>
+          </a:p>
+        </p:txBody>
+      </p:sp>
+      <p:sp>
+        <p:nvSpPr>
+          <p:cNvPr id="8" name="Text 5"/>
           <p:cNvSpPr txBox="1"/>
           <p:nvPr/>
         </p:nvSpPr>
         <p:spPr>
           <a:xfrm>
-            <a:off x="8503920" y="2880360"/>
-            <a:ext cx="2834640" cy="822960"/>
+            <a:off x="822960" y="3200400"/>
+            <a:ext cx="3291840" cy="640080"/>
           </a:xfrm>
           <a:prstGeom prst="rect">
             <a:avLst/>
@@ -5497,30 +5686,30 @@
               <a:buNone/>
             </a:pPr>
             <a:r>
-              <a:rPr lang="en-US" sz="1400" dirty="0">
-                <a:solidFill>
-                  <a:srgbClr val="5F6672"/>
+              <a:rPr lang="en-US" sz="1600" dirty="0">
+                <a:solidFill>
+                  <a:srgbClr val="0F1D30"/>
                 </a:solidFill>
                 <a:latin typeface="Calibri" pitchFamily="34" charset="0"/>
                 <a:ea typeface="Calibri" pitchFamily="34" charset="-122"/>
                 <a:cs typeface="Calibri" pitchFamily="34" charset="-120"/>
               </a:rPr>
-              <a:t>As-Is process cycle efficiency</a:t>
-            </a:r>
-            <a:endParaRPr lang="en-US" sz="1400" dirty="0"/>
-          </a:p>
-        </p:txBody>
-      </p:sp>
-      <p:sp>
-        <p:nvSpPr>
-          <p:cNvPr id="9" name="Text 5"/>
+              <a:t>of the 18.6 h is waiting, moving or rework</a:t>
+            </a:r>
+            <a:endParaRPr lang="en-US" sz="1600" dirty="0"/>
+          </a:p>
+        </p:txBody>
+      </p:sp>
+      <p:sp>
+        <p:nvSpPr>
+          <p:cNvPr id="9" name="Text 6"/>
           <p:cNvSpPr txBox="1"/>
           <p:nvPr/>
         </p:nvSpPr>
         <p:spPr>
           <a:xfrm>
-            <a:off x="8503920" y="3840480"/>
-            <a:ext cx="2834640" cy="822960"/>
+            <a:off x="822960" y="4206240"/>
+            <a:ext cx="3291840" cy="914400"/>
           </a:xfrm>
           <a:prstGeom prst="rect">
             <a:avLst/>
@@ -5529,53 +5718,14 @@
           <a:ln/>
         </p:spPr>
         <p:txBody>
-          <a:bodyPr wrap="square" lIns="0" tIns="0" rIns="0" bIns="0" rtlCol="0" anchor="ctr"/>
+          <a:bodyPr wrap="square" lIns="0" tIns="0" rIns="0" bIns="0" rtlCol="0" anchor="t"/>
           <a:lstStyle/>
           <a:p>
             <a:pPr indent="0" marL="0">
               <a:buNone/>
             </a:pPr>
             <a:r>
-              <a:rPr lang="en-US" sz="4000" b="1" dirty="0">
-                <a:solidFill>
-                  <a:srgbClr val="2A78D6"/>
-                </a:solidFill>
-                <a:latin typeface="Cambria" pitchFamily="34" charset="0"/>
-                <a:ea typeface="Cambria" pitchFamily="34" charset="-122"/>
-                <a:cs typeface="Cambria" pitchFamily="34" charset="-120"/>
-              </a:rPr>
-              <a:t>15.22%</a:t>
-            </a:r>
-            <a:endParaRPr lang="en-US" sz="4000" dirty="0"/>
-          </a:p>
-        </p:txBody>
-      </p:sp>
-      <p:sp>
-        <p:nvSpPr>
-          <p:cNvPr id="10" name="Text 6"/>
-          <p:cNvSpPr txBox="1"/>
-          <p:nvPr/>
-        </p:nvSpPr>
-        <p:spPr>
-          <a:xfrm>
-            <a:off x="8503920" y="4709160"/>
-            <a:ext cx="2834640" cy="822960"/>
-          </a:xfrm>
-          <a:prstGeom prst="rect">
-            <a:avLst/>
-          </a:prstGeom>
-          <a:noFill/>
-          <a:ln/>
-        </p:spPr>
-        <p:txBody>
-          <a:bodyPr wrap="square" lIns="0" tIns="0" rIns="0" bIns="0" rtlCol="0" anchor="t"/>
-          <a:lstStyle/>
-          <a:p>
-            <a:pPr indent="0" marL="0">
-              <a:buNone/>
-            </a:pPr>
-            <a:r>
-              <a:rPr lang="en-US" sz="1400" dirty="0">
+              <a:rPr lang="en-US" sz="1300" dirty="0">
                 <a:solidFill>
                   <a:srgbClr val="5F6672"/>
                 </a:solidFill>
@@ -5583,12 +5733,45 @@
                 <a:ea typeface="Calibri" pitchFamily="34" charset="-122"/>
                 <a:cs typeface="Calibri" pitchFamily="34" charset="-120"/>
               </a:rPr>
-              <a:t>To-Be, above the 15% benchmark</a:t>
-            </a:r>
-            <a:endParaRPr lang="en-US" sz="1400" dirty="0"/>
-          </a:p>
-        </p:txBody>
-      </p:sp>
+              <a:t>Process cycle efficiency: 3.76% today</a:t>
+            </a:r>
+            <a:endParaRPr lang="en-US" sz="1300" dirty="0"/>
+          </a:p>
+          <a:p>
+            <a:pPr indent="0" marL="0">
+              <a:buNone/>
+            </a:pPr>
+            <a:r>
+              <a:rPr lang="en-US" sz="1300" dirty="0">
+                <a:solidFill>
+                  <a:srgbClr val="5F6672"/>
+                </a:solidFill>
+                <a:latin typeface="Calibri" pitchFamily="34" charset="0"/>
+                <a:ea typeface="Calibri" pitchFamily="34" charset="-122"/>
+                <a:cs typeface="Calibri" pitchFamily="34" charset="-120"/>
+              </a:rPr>
+              <a:t>15.22% after the redesign (benchmark above 15%)</a:t>
+            </a:r>
+            <a:endParaRPr lang="en-US" sz="1300" dirty="0"/>
+          </a:p>
+        </p:txBody>
+      </p:sp>
+      <p:graphicFrame>
+        <p:nvGraphicFramePr>
+          <p:cNvPr id="10" name="Chart 0" descr=""/>
+          <p:cNvGraphicFramePr/>
+          <p:nvPr/>
+        </p:nvGraphicFramePr>
+        <p:xfrm>
+          <a:off x="4663440" y="1783080"/>
+          <a:ext cx="6949440" cy="4206240"/>
+        </p:xfrm>
+        <a:graphic xmlns:a="http://schemas.openxmlformats.org/drawingml/2006/main">
+          <a:graphicData uri="http://schemas.openxmlformats.org/drawingml/2006/chart">
+            <c:chart xmlns:c="http://schemas.openxmlformats.org/drawingml/2006/chart" r:id="rId1"/>
+          </a:graphicData>
+        </a:graphic>
+      </p:graphicFrame>
       <p:sp>
         <p:nvSpPr>
           <p:cNvPr id="25" name="Slide Number Placeholder 0"/>
@@ -5714,7 +5897,7 @@
         <p:spPr>
           <a:xfrm>
             <a:off x="548640" y="731520"/>
-            <a:ext cx="11064240" cy="822960"/>
+            <a:ext cx="11064240" cy="548640"/>
           </a:xfrm>
           <a:prstGeom prst="rect">
             <a:avLst/>
@@ -5730,7 +5913,7 @@
               <a:buNone/>
             </a:pPr>
             <a:r>
-              <a:rPr lang="en-US" sz="3000" b="1" dirty="0">
+              <a:rPr lang="en-US" sz="2800" b="1" dirty="0">
                 <a:solidFill>
                   <a:srgbClr val="0F1D30"/>
                 </a:solidFill>
@@ -5740,13 +5923,52 @@
               </a:rPr>
               <a:t>The delay costs $6.0M a year before patient risk</a:t>
             </a:r>
-            <a:endParaRPr lang="en-US" sz="3000" dirty="0"/>
-          </a:p>
-        </p:txBody>
-      </p:sp>
-      <p:sp>
-        <p:nvSpPr>
-          <p:cNvPr id="5" name="impact-1"/>
+            <a:endParaRPr lang="en-US" sz="2800" dirty="0"/>
+          </a:p>
+        </p:txBody>
+      </p:sp>
+      <p:sp>
+        <p:nvSpPr>
+          <p:cNvPr id="4" name="subtitle"/>
+          <p:cNvSpPr txBox="1"/>
+          <p:nvPr/>
+        </p:nvSpPr>
+        <p:spPr>
+          <a:xfrm>
+            <a:off x="548640" y="1298448"/>
+            <a:ext cx="11064240" cy="365760"/>
+          </a:xfrm>
+          <a:prstGeom prst="rect">
+            <a:avLst/>
+          </a:prstGeom>
+          <a:noFill/>
+          <a:ln/>
+        </p:spPr>
+        <p:txBody>
+          <a:bodyPr wrap="square" lIns="0" tIns="0" rIns="0" bIns="0" rtlCol="0" anchor="ctr"/>
+          <a:lstStyle/>
+          <a:p>
+            <a:pPr indent="0" marL="0">
+              <a:buNone/>
+            </a:pPr>
+            <a:r>
+              <a:rPr lang="en-US" sz="1600" dirty="0">
+                <a:solidFill>
+                  <a:srgbClr val="5F6672"/>
+                </a:solidFill>
+                <a:latin typeface="Calibri" pitchFamily="34" charset="0"/>
+                <a:ea typeface="Calibri" pitchFamily="34" charset="-122"/>
+                <a:cs typeface="Calibri" pitchFamily="34" charset="-120"/>
+              </a:rPr>
+              <a:t>Hospital penalties and overtime come straight out of the budget.</a:t>
+            </a:r>
+            <a:endParaRPr lang="en-US" sz="1600" dirty="0"/>
+          </a:p>
+        </p:txBody>
+      </p:sp>
+      <p:sp>
+        <p:nvSpPr>
+          <p:cNvPr id="6" name="impact-1"/>
           <p:cNvSpPr/>
           <p:nvPr/>
         </p:nvSpPr>
@@ -5773,7 +5995,7 @@
       </p:sp>
       <p:sp>
         <p:nvSpPr>
-          <p:cNvPr id="6" name="Text 3"/>
+          <p:cNvPr id="7" name="Text 4"/>
           <p:cNvSpPr txBox="1"/>
           <p:nvPr/>
         </p:nvSpPr>
@@ -5812,7 +6034,7 @@
       </p:sp>
       <p:sp>
         <p:nvSpPr>
-          <p:cNvPr id="7" name="Text 4"/>
+          <p:cNvPr id="8" name="Text 5"/>
           <p:cNvSpPr txBox="1"/>
           <p:nvPr/>
         </p:nvSpPr>
@@ -5851,7 +6073,7 @@
       </p:sp>
       <p:sp>
         <p:nvSpPr>
-          <p:cNvPr id="8" name="impact-2"/>
+          <p:cNvPr id="9" name="impact-2"/>
           <p:cNvSpPr/>
           <p:nvPr/>
         </p:nvSpPr>
@@ -5878,7 +6100,7 @@
       </p:sp>
       <p:sp>
         <p:nvSpPr>
-          <p:cNvPr id="9" name="Text 6"/>
+          <p:cNvPr id="10" name="Text 7"/>
           <p:cNvSpPr txBox="1"/>
           <p:nvPr/>
         </p:nvSpPr>
@@ -5917,7 +6139,7 @@
       </p:sp>
       <p:sp>
         <p:nvSpPr>
-          <p:cNvPr id="10" name="Text 7"/>
+          <p:cNvPr id="11" name="Text 8"/>
           <p:cNvSpPr txBox="1"/>
           <p:nvPr/>
         </p:nvSpPr>
@@ -5956,7 +6178,7 @@
       </p:sp>
       <p:sp>
         <p:nvSpPr>
-          <p:cNvPr id="11" name="impact-3"/>
+          <p:cNvPr id="12" name="impact-3"/>
           <p:cNvSpPr/>
           <p:nvPr/>
         </p:nvSpPr>
@@ -5983,7 +6205,7 @@
       </p:sp>
       <p:sp>
         <p:nvSpPr>
-          <p:cNvPr id="12" name="Text 9"/>
+          <p:cNvPr id="13" name="Text 10"/>
           <p:cNvSpPr txBox="1"/>
           <p:nvPr/>
         </p:nvSpPr>
@@ -6022,7 +6244,7 @@
       </p:sp>
       <p:sp>
         <p:nvSpPr>
-          <p:cNvPr id="13" name="Text 10"/>
+          <p:cNvPr id="14" name="Text 11"/>
           <p:cNvSpPr txBox="1"/>
           <p:nvPr/>
         </p:nvSpPr>
@@ -6061,7 +6283,7 @@
       </p:sp>
       <p:sp>
         <p:nvSpPr>
-          <p:cNvPr id="14" name="impact-4"/>
+          <p:cNvPr id="15" name="impact-4"/>
           <p:cNvSpPr/>
           <p:nvPr/>
         </p:nvSpPr>
@@ -6088,7 +6310,7 @@
       </p:sp>
       <p:sp>
         <p:nvSpPr>
-          <p:cNvPr id="15" name="Text 12"/>
+          <p:cNvPr id="16" name="Text 13"/>
           <p:cNvSpPr txBox="1"/>
           <p:nvPr/>
         </p:nvSpPr>
@@ -6127,7 +6349,7 @@
       </p:sp>
       <p:sp>
         <p:nvSpPr>
-          <p:cNvPr id="16" name="Text 13"/>
+          <p:cNvPr id="17" name="Text 14"/>
           <p:cNvSpPr txBox="1"/>
           <p:nvPr/>
         </p:nvSpPr>
@@ -6166,7 +6388,7 @@
       </p:sp>
       <p:sp>
         <p:nvSpPr>
-          <p:cNvPr id="17" name="Text 14"/>
+          <p:cNvPr id="18" name="Text 15"/>
           <p:cNvSpPr txBox="1"/>
           <p:nvPr/>
         </p:nvSpPr>
@@ -6328,7 +6550,7 @@
         <p:spPr>
           <a:xfrm>
             <a:off x="548640" y="731520"/>
-            <a:ext cx="11064240" cy="822960"/>
+            <a:ext cx="11064240" cy="548640"/>
           </a:xfrm>
           <a:prstGeom prst="rect">
             <a:avLst/>
@@ -6344,7 +6566,7 @@
               <a:buNone/>
             </a:pPr>
             <a:r>
-              <a:rPr lang="en-US" sz="3000" b="1" dirty="0">
+              <a:rPr lang="en-US" sz="2800" b="1" dirty="0">
                 <a:solidFill>
                   <a:srgbClr val="0F1D30"/>
                 </a:solidFill>
@@ -6352,15 +6574,54 @@
                 <a:ea typeface="Cambria" pitchFamily="34" charset="-122"/>
                 <a:cs typeface="Cambria" pitchFamily="34" charset="-120"/>
               </a:rPr>
-              <a:t>Five lanes, 12 steps, no manual handoffs</a:t>
-            </a:r>
-            <a:endParaRPr lang="en-US" sz="3000" dirty="0"/>
-          </a:p>
-        </p:txBody>
-      </p:sp>
-      <p:sp>
-        <p:nvSpPr>
-          <p:cNvPr id="5" name="lane-1"/>
+              <a:t>The new process has 12 steps and no retyping</a:t>
+            </a:r>
+            <a:endParaRPr lang="en-US" sz="2800" dirty="0"/>
+          </a:p>
+        </p:txBody>
+      </p:sp>
+      <p:sp>
+        <p:nvSpPr>
+          <p:cNvPr id="4" name="subtitle"/>
+          <p:cNvSpPr txBox="1"/>
+          <p:nvPr/>
+        </p:nvSpPr>
+        <p:spPr>
+          <a:xfrm>
+            <a:off x="548640" y="1298448"/>
+            <a:ext cx="11064240" cy="365760"/>
+          </a:xfrm>
+          <a:prstGeom prst="rect">
+            <a:avLst/>
+          </a:prstGeom>
+          <a:noFill/>
+          <a:ln/>
+        </p:spPr>
+        <p:txBody>
+          <a:bodyPr wrap="square" lIns="0" tIns="0" rIns="0" bIns="0" rtlCol="0" anchor="ctr"/>
+          <a:lstStyle/>
+          <a:p>
+            <a:pPr indent="0" marL="0">
+              <a:buNone/>
+            </a:pPr>
+            <a:r>
+              <a:rPr lang="en-US" sz="1600" dirty="0">
+                <a:solidFill>
+                  <a:srgbClr val="5F6672"/>
+                </a:solidFill>
+                <a:latin typeface="Calibri" pitchFamily="34" charset="0"/>
+                <a:ea typeface="Calibri" pitchFamily="34" charset="-122"/>
+                <a:cs typeface="Calibri" pitchFamily="34" charset="-120"/>
+              </a:rPr>
+              <a:t>Scans and automatic messages replace the steps where people retyped data.</a:t>
+            </a:r>
+            <a:endParaRPr lang="en-US" sz="1600" dirty="0"/>
+          </a:p>
+        </p:txBody>
+      </p:sp>
+      <p:sp>
+        <p:nvSpPr>
+          <p:cNvPr id="6" name="lane-1"/>
           <p:cNvSpPr/>
           <p:nvPr/>
         </p:nvSpPr>
@@ -6387,7 +6648,7 @@
       </p:sp>
       <p:sp>
         <p:nvSpPr>
-          <p:cNvPr id="6" name="Text 3"/>
+          <p:cNvPr id="7" name="Text 4"/>
           <p:cNvSpPr txBox="1"/>
           <p:nvPr/>
         </p:nvSpPr>
@@ -6426,7 +6687,7 @@
       </p:sp>
       <p:sp>
         <p:nvSpPr>
-          <p:cNvPr id="7" name="Text 4"/>
+          <p:cNvPr id="8" name="Text 5"/>
           <p:cNvSpPr txBox="1"/>
           <p:nvPr/>
         </p:nvSpPr>
@@ -6465,7 +6726,7 @@
       </p:sp>
       <p:sp>
         <p:nvSpPr>
-          <p:cNvPr id="8" name="Text 5"/>
+          <p:cNvPr id="9" name="Text 6"/>
           <p:cNvSpPr txBox="1"/>
           <p:nvPr/>
         </p:nvSpPr>
@@ -6504,7 +6765,7 @@
       </p:sp>
       <p:sp>
         <p:nvSpPr>
-          <p:cNvPr id="9" name="Shape 6"/>
+          <p:cNvPr id="10" name="Shape 7"/>
           <p:cNvSpPr/>
           <p:nvPr/>
         </p:nvSpPr>
@@ -6529,7 +6790,7 @@
       </p:sp>
       <p:sp>
         <p:nvSpPr>
-          <p:cNvPr id="10" name="lane-2"/>
+          <p:cNvPr id="11" name="lane-2"/>
           <p:cNvSpPr/>
           <p:nvPr/>
         </p:nvSpPr>
@@ -6556,7 +6817,7 @@
       </p:sp>
       <p:sp>
         <p:nvSpPr>
-          <p:cNvPr id="11" name="Text 8"/>
+          <p:cNvPr id="12" name="Text 9"/>
           <p:cNvSpPr txBox="1"/>
           <p:nvPr/>
         </p:nvSpPr>
@@ -6595,7 +6856,7 @@
       </p:sp>
       <p:sp>
         <p:nvSpPr>
-          <p:cNvPr id="12" name="Text 9"/>
+          <p:cNvPr id="13" name="Text 10"/>
           <p:cNvSpPr txBox="1"/>
           <p:nvPr/>
         </p:nvSpPr>
@@ -6634,7 +6895,7 @@
       </p:sp>
       <p:sp>
         <p:nvSpPr>
-          <p:cNvPr id="13" name="Text 10"/>
+          <p:cNvPr id="14" name="Text 11"/>
           <p:cNvSpPr txBox="1"/>
           <p:nvPr/>
         </p:nvSpPr>
@@ -6673,7 +6934,7 @@
       </p:sp>
       <p:sp>
         <p:nvSpPr>
-          <p:cNvPr id="14" name="Shape 11"/>
+          <p:cNvPr id="15" name="Shape 12"/>
           <p:cNvSpPr/>
           <p:nvPr/>
         </p:nvSpPr>
@@ -6698,7 +6959,7 @@
       </p:sp>
       <p:sp>
         <p:nvSpPr>
-          <p:cNvPr id="15" name="lane-3"/>
+          <p:cNvPr id="16" name="lane-3"/>
           <p:cNvSpPr/>
           <p:nvPr/>
         </p:nvSpPr>
@@ -6725,7 +6986,7 @@
       </p:sp>
       <p:sp>
         <p:nvSpPr>
-          <p:cNvPr id="16" name="Text 13"/>
+          <p:cNvPr id="17" name="Text 14"/>
           <p:cNvSpPr txBox="1"/>
           <p:nvPr/>
         </p:nvSpPr>
@@ -6764,7 +7025,7 @@
       </p:sp>
       <p:sp>
         <p:nvSpPr>
-          <p:cNvPr id="17" name="Text 14"/>
+          <p:cNvPr id="18" name="Text 15"/>
           <p:cNvSpPr txBox="1"/>
           <p:nvPr/>
         </p:nvSpPr>
@@ -6803,7 +7064,7 @@
       </p:sp>
       <p:sp>
         <p:nvSpPr>
-          <p:cNvPr id="18" name="Text 15"/>
+          <p:cNvPr id="19" name="Text 16"/>
           <p:cNvSpPr txBox="1"/>
           <p:nvPr/>
         </p:nvSpPr>
@@ -6842,7 +7103,7 @@
       </p:sp>
       <p:sp>
         <p:nvSpPr>
-          <p:cNvPr id="19" name="Shape 16"/>
+          <p:cNvPr id="20" name="Shape 17"/>
           <p:cNvSpPr/>
           <p:nvPr/>
         </p:nvSpPr>
@@ -6867,7 +7128,7 @@
       </p:sp>
       <p:sp>
         <p:nvSpPr>
-          <p:cNvPr id="20" name="lane-4"/>
+          <p:cNvPr id="21" name="lane-4"/>
           <p:cNvSpPr/>
           <p:nvPr/>
         </p:nvSpPr>
@@ -6894,7 +7155,7 @@
       </p:sp>
       <p:sp>
         <p:nvSpPr>
-          <p:cNvPr id="21" name="Text 18"/>
+          <p:cNvPr id="22" name="Text 19"/>
           <p:cNvSpPr txBox="1"/>
           <p:nvPr/>
         </p:nvSpPr>
@@ -6933,7 +7194,7 @@
       </p:sp>
       <p:sp>
         <p:nvSpPr>
-          <p:cNvPr id="22" name="Text 19"/>
+          <p:cNvPr id="23" name="Text 20"/>
           <p:cNvSpPr txBox="1"/>
           <p:nvPr/>
         </p:nvSpPr>
@@ -6972,7 +7233,7 @@
       </p:sp>
       <p:sp>
         <p:nvSpPr>
-          <p:cNvPr id="23" name="Text 20"/>
+          <p:cNvPr id="24" name="Text 21"/>
           <p:cNvSpPr txBox="1"/>
           <p:nvPr/>
         </p:nvSpPr>
@@ -7011,7 +7272,7 @@
       </p:sp>
       <p:sp>
         <p:nvSpPr>
-          <p:cNvPr id="24" name="Shape 21"/>
+          <p:cNvPr id="25" name="Shape 22"/>
           <p:cNvSpPr/>
           <p:nvPr/>
         </p:nvSpPr>
@@ -7036,7 +7297,7 @@
       </p:sp>
       <p:sp>
         <p:nvSpPr>
-          <p:cNvPr id="25" name="lane-5"/>
+          <p:cNvPr id="26" name="lane-5"/>
           <p:cNvSpPr/>
           <p:nvPr/>
         </p:nvSpPr>
@@ -7063,7 +7324,7 @@
       </p:sp>
       <p:sp>
         <p:nvSpPr>
-          <p:cNvPr id="26" name="Text 23"/>
+          <p:cNvPr id="27" name="Text 24"/>
           <p:cNvSpPr txBox="1"/>
           <p:nvPr/>
         </p:nvSpPr>
@@ -7102,7 +7363,7 @@
       </p:sp>
       <p:sp>
         <p:nvSpPr>
-          <p:cNvPr id="27" name="Text 24"/>
+          <p:cNvPr id="28" name="Text 25"/>
           <p:cNvSpPr txBox="1"/>
           <p:nvPr/>
         </p:nvSpPr>
@@ -7141,7 +7402,7 @@
       </p:sp>
       <p:sp>
         <p:nvSpPr>
-          <p:cNvPr id="28" name="Text 25"/>
+          <p:cNvPr id="29" name="Text 26"/>
           <p:cNvSpPr txBox="1"/>
           <p:nvPr/>
         </p:nvSpPr>
@@ -7180,7 +7441,7 @@
       </p:sp>
       <p:sp>
         <p:nvSpPr>
-          <p:cNvPr id="29" name="Text 26"/>
+          <p:cNvPr id="30" name="Text 27"/>
           <p:cNvSpPr txBox="1"/>
           <p:nvPr/>
         </p:nvSpPr>
@@ -7342,7 +7603,7 @@
         <p:spPr>
           <a:xfrm>
             <a:off x="548640" y="731520"/>
-            <a:ext cx="11064240" cy="822960"/>
+            <a:ext cx="11064240" cy="548640"/>
           </a:xfrm>
           <a:prstGeom prst="rect">
             <a:avLst/>
@@ -7358,7 +7619,7 @@
               <a:buNone/>
             </a:pPr>
             <a:r>
-              <a:rPr lang="en-US" sz="3000" b="1" dirty="0">
+              <a:rPr lang="en-US" sz="2800" b="1" dirty="0">
                 <a:solidFill>
                   <a:srgbClr val="0F1D30"/>
                 </a:solidFill>
@@ -7368,7 +7629,46 @@
               </a:rPr>
               <a:t>Four changes, each aimed at one queue</a:t>
             </a:r>
-            <a:endParaRPr lang="en-US" sz="3000" dirty="0"/>
+            <a:endParaRPr lang="en-US" sz="2800" dirty="0"/>
+          </a:p>
+        </p:txBody>
+      </p:sp>
+      <p:sp>
+        <p:nvSpPr>
+          <p:cNvPr id="4" name="subtitle"/>
+          <p:cNvSpPr txBox="1"/>
+          <p:nvPr/>
+        </p:nvSpPr>
+        <p:spPr>
+          <a:xfrm>
+            <a:off x="548640" y="1298448"/>
+            <a:ext cx="11064240" cy="365760"/>
+          </a:xfrm>
+          <a:prstGeom prst="rect">
+            <a:avLst/>
+          </a:prstGeom>
+          <a:noFill/>
+          <a:ln/>
+        </p:spPr>
+        <p:txBody>
+          <a:bodyPr wrap="square" lIns="0" tIns="0" rIns="0" bIns="0" rtlCol="0" anchor="ctr"/>
+          <a:lstStyle/>
+          <a:p>
+            <a:pPr indent="0" marL="0">
+              <a:buNone/>
+            </a:pPr>
+            <a:r>
+              <a:rPr lang="en-US" sz="1600" dirty="0">
+                <a:solidFill>
+                  <a:srgbClr val="5F6672"/>
+                </a:solidFill>
+                <a:latin typeface="Calibri" pitchFamily="34" charset="0"/>
+                <a:ea typeface="Calibri" pitchFamily="34" charset="-122"/>
+                <a:cs typeface="Calibri" pitchFamily="34" charset="-120"/>
+              </a:rPr>
+              <a:t>None of the fixes depend on staff working faster.</a:t>
+            </a:r>
+            <a:endParaRPr lang="en-US" sz="1600" dirty="0"/>
           </a:p>
         </p:txBody>
       </p:sp>
@@ -8728,7 +9028,7 @@
       </p:graphicFrame>
       <p:sp>
         <p:nvSpPr>
-          <p:cNvPr id="6" name="Text 2"/>
+          <p:cNvPr id="7" name="Text 3"/>
           <p:cNvSpPr txBox="1"/>
           <p:nvPr/>
         </p:nvSpPr>
@@ -8890,7 +9190,7 @@
         <p:spPr>
           <a:xfrm>
             <a:off x="548640" y="731520"/>
-            <a:ext cx="11064240" cy="822960"/>
+            <a:ext cx="11064240" cy="548640"/>
           </a:xfrm>
           <a:prstGeom prst="rect">
             <a:avLst/>
@@ -8906,7 +9206,7 @@
               <a:buNone/>
             </a:pPr>
             <a:r>
-              <a:rPr lang="en-US" sz="3000" b="1" dirty="0">
+              <a:rPr lang="en-US" sz="2800" b="1" dirty="0">
                 <a:solidFill>
                   <a:srgbClr val="0F1D30"/>
                 </a:solidFill>
@@ -8916,7 +9216,46 @@
               </a:rPr>
               <a:t>75.3% faster, $4.35M a year, paid back in 1.4 months</a:t>
             </a:r>
-            <a:endParaRPr lang="en-US" sz="3000" dirty="0"/>
+            <a:endParaRPr lang="en-US" sz="2800" dirty="0"/>
+          </a:p>
+        </p:txBody>
+      </p:sp>
+      <p:sp>
+        <p:nvSpPr>
+          <p:cNvPr id="4" name="subtitle"/>
+          <p:cNvSpPr txBox="1"/>
+          <p:nvPr/>
+        </p:nvSpPr>
+        <p:spPr>
+          <a:xfrm>
+            <a:off x="548640" y="1298448"/>
+            <a:ext cx="11064240" cy="365760"/>
+          </a:xfrm>
+          <a:prstGeom prst="rect">
+            <a:avLst/>
+          </a:prstGeom>
+          <a:noFill/>
+          <a:ln/>
+        </p:spPr>
+        <p:txBody>
+          <a:bodyPr wrap="square" lIns="0" tIns="0" rIns="0" bIns="0" rtlCol="0" anchor="ctr"/>
+          <a:lstStyle/>
+          <a:p>
+            <a:pPr indent="0" marL="0">
+              <a:buNone/>
+            </a:pPr>
+            <a:r>
+              <a:rPr lang="en-US" sz="1600" dirty="0">
+                <a:solidFill>
+                  <a:srgbClr val="5F6672"/>
+                </a:solidFill>
+                <a:latin typeface="Calibri" pitchFamily="34" charset="0"/>
+                <a:ea typeface="Calibri" pitchFamily="34" charset="-122"/>
+                <a:cs typeface="Calibri" pitchFamily="34" charset="-120"/>
+              </a:rPr>
+              <a:t>The money comes back within two months, and every quality measure improves.</a:t>
+            </a:r>
+            <a:endParaRPr lang="en-US" sz="1600" dirty="0"/>
           </a:p>
         </p:txBody>
       </p:sp>
@@ -10341,7 +10680,7 @@
       </p:graphicFrame>
       <p:sp>
         <p:nvSpPr>
-          <p:cNvPr id="6" name="roi-1"/>
+          <p:cNvPr id="7" name="roi-1"/>
           <p:cNvSpPr/>
           <p:nvPr/>
         </p:nvSpPr>
@@ -10368,7 +10707,7 @@
       </p:sp>
       <p:sp>
         <p:nvSpPr>
-          <p:cNvPr id="7" name="Text 3"/>
+          <p:cNvPr id="8" name="Text 4"/>
           <p:cNvSpPr txBox="1"/>
           <p:nvPr/>
         </p:nvSpPr>
@@ -10407,7 +10746,7 @@
       </p:sp>
       <p:sp>
         <p:nvSpPr>
-          <p:cNvPr id="8" name="Text 4"/>
+          <p:cNvPr id="9" name="Text 5"/>
           <p:cNvSpPr txBox="1"/>
           <p:nvPr/>
         </p:nvSpPr>
@@ -10446,7 +10785,7 @@
       </p:sp>
       <p:sp>
         <p:nvSpPr>
-          <p:cNvPr id="9" name="roi-2"/>
+          <p:cNvPr id="10" name="roi-2"/>
           <p:cNvSpPr/>
           <p:nvPr/>
         </p:nvSpPr>
@@ -10473,7 +10812,7 @@
       </p:sp>
       <p:sp>
         <p:nvSpPr>
-          <p:cNvPr id="10" name="Text 6"/>
+          <p:cNvPr id="11" name="Text 7"/>
           <p:cNvSpPr txBox="1"/>
           <p:nvPr/>
         </p:nvSpPr>
@@ -10512,7 +10851,7 @@
       </p:sp>
       <p:sp>
         <p:nvSpPr>
-          <p:cNvPr id="11" name="Text 7"/>
+          <p:cNvPr id="12" name="Text 8"/>
           <p:cNvSpPr txBox="1"/>
           <p:nvPr/>
         </p:nvSpPr>
@@ -10551,7 +10890,7 @@
       </p:sp>
       <p:sp>
         <p:nvSpPr>
-          <p:cNvPr id="12" name="roi-3"/>
+          <p:cNvPr id="13" name="roi-3"/>
           <p:cNvSpPr/>
           <p:nvPr/>
         </p:nvSpPr>
@@ -10578,7 +10917,7 @@
       </p:sp>
       <p:sp>
         <p:nvSpPr>
-          <p:cNvPr id="13" name="Text 9"/>
+          <p:cNvPr id="14" name="Text 10"/>
           <p:cNvSpPr txBox="1"/>
           <p:nvPr/>
         </p:nvSpPr>
@@ -10617,7 +10956,7 @@
       </p:sp>
       <p:sp>
         <p:nvSpPr>
-          <p:cNvPr id="14" name="Text 10"/>
+          <p:cNvPr id="15" name="Text 11"/>
           <p:cNvSpPr txBox="1"/>
           <p:nvPr/>
         </p:nvSpPr>

</xml_diff>

<commit_message>
fix(deck): clearer slide 3, 8, 9 and 10 copy and spacing
Co-Authored-By: Claude Opus 5.5 <noreply@anthropic.com>
</commit_message>
<xml_diff>
--- a/deck/sovereign-health-exec-briefing.pptx
+++ b/deck/sovereign-health-exec-briefing.pptx
@@ -116,21 +116,21 @@
   <p:extLst>
     <p:ext uri="{521415D9-36F7-43E2-AB2F-B90AF26B5E84}">
       <p14:sectionLst xmlns:p14="http://schemas.microsoft.com/office/powerpoint/2010/main">
-        <p14:section name="What?" id="{c4fd91df-e933-6f8d-a143-67aae04db7c8}">
+        <p14:section name="What?" id="{3ae859fa-88f0-1b5e-0e63-4f9fefe55699}">
           <p14:sldIdLst>
             <p14:sldId id="256"/>
             <p14:sldId id="257"/>
             <p14:sldId id="258"/>
           </p14:sldIdLst>
         </p14:section>
-        <p14:section name="So What?" id="{188a2480-1ac3-c65e-5a09-f1c9d87e632d}">
+        <p14:section name="So What?" id="{d8b120e7-8a46-edbd-8bce-19428de9a015}">
           <p14:sldIdLst>
             <p14:sldId id="259"/>
             <p14:sldId id="260"/>
             <p14:sldId id="261"/>
           </p14:sldIdLst>
         </p14:section>
-        <p14:section name="Now What?" id="{4d7e95ce-4cc6-54a3-5b56-6584a5b151b9}">
+        <p14:section name="Now What?" id="{ce1888df-d44b-35cb-27ae-412ec9989c87}">
           <p14:sldIdLst>
             <p14:sldId id="262"/>
             <p14:sldId id="263"/>
@@ -3010,7 +3010,7 @@
         </p:nvSpPr>
         <p:spPr>
           <a:xfrm>
-            <a:off x="731520" y="2148840"/>
+            <a:off x="731520" y="2834640"/>
             <a:ext cx="10698480" cy="457200"/>
           </a:xfrm>
           <a:prstGeom prst="rect">
@@ -3049,7 +3049,7 @@
         </p:nvSpPr>
         <p:spPr>
           <a:xfrm>
-            <a:off x="731520" y="2743200"/>
+            <a:off x="731520" y="3383280"/>
             <a:ext cx="3840480" cy="365760"/>
           </a:xfrm>
           <a:prstGeom prst="rect">
@@ -3088,7 +3088,7 @@
         </p:nvSpPr>
         <p:spPr>
           <a:xfrm>
-            <a:off x="4754880" y="2798064"/>
+            <a:off x="4754880" y="3438144"/>
             <a:ext cx="6675120" cy="256032"/>
           </a:xfrm>
           <a:prstGeom prst="rect">
@@ -3113,7 +3113,7 @@
         </p:nvSpPr>
         <p:spPr>
           <a:xfrm>
-            <a:off x="4754880" y="2798064"/>
+            <a:off x="4754880" y="3438144"/>
             <a:ext cx="834390" cy="256032"/>
           </a:xfrm>
           <a:prstGeom prst="roundRect">
@@ -3140,7 +3140,7 @@
         </p:nvSpPr>
         <p:spPr>
           <a:xfrm>
-            <a:off x="731520" y="3182112"/>
+            <a:off x="731520" y="3767328"/>
             <a:ext cx="3840480" cy="365760"/>
           </a:xfrm>
           <a:prstGeom prst="rect">
@@ -3179,7 +3179,7 @@
         </p:nvSpPr>
         <p:spPr>
           <a:xfrm>
-            <a:off x="4754880" y="3236976"/>
+            <a:off x="4754880" y="3822192"/>
             <a:ext cx="6675120" cy="256032"/>
           </a:xfrm>
           <a:prstGeom prst="rect">
@@ -3204,7 +3204,7 @@
         </p:nvSpPr>
         <p:spPr>
           <a:xfrm>
-            <a:off x="5589270" y="3236976"/>
+            <a:off x="5589270" y="3822192"/>
             <a:ext cx="1251585" cy="256032"/>
           </a:xfrm>
           <a:prstGeom prst="roundRect">
@@ -3231,7 +3231,7 @@
         </p:nvSpPr>
         <p:spPr>
           <a:xfrm>
-            <a:off x="731520" y="3621024"/>
+            <a:off x="731520" y="4151376"/>
             <a:ext cx="3840480" cy="365760"/>
           </a:xfrm>
           <a:prstGeom prst="rect">
@@ -3270,7 +3270,7 @@
         </p:nvSpPr>
         <p:spPr>
           <a:xfrm>
-            <a:off x="4754880" y="3675888"/>
+            <a:off x="4754880" y="4206240"/>
             <a:ext cx="6675120" cy="256032"/>
           </a:xfrm>
           <a:prstGeom prst="rect">
@@ -3295,7 +3295,7 @@
         </p:nvSpPr>
         <p:spPr>
           <a:xfrm>
-            <a:off x="6840855" y="3675888"/>
+            <a:off x="6840855" y="4206240"/>
             <a:ext cx="834390" cy="256032"/>
           </a:xfrm>
           <a:prstGeom prst="roundRect">
@@ -3322,7 +3322,7 @@
         </p:nvSpPr>
         <p:spPr>
           <a:xfrm>
-            <a:off x="731520" y="4059936"/>
+            <a:off x="731520" y="4535424"/>
             <a:ext cx="3840480" cy="365760"/>
           </a:xfrm>
           <a:prstGeom prst="rect">
@@ -3361,7 +3361,7 @@
         </p:nvSpPr>
         <p:spPr>
           <a:xfrm>
-            <a:off x="4754880" y="4114800"/>
+            <a:off x="4754880" y="4590288"/>
             <a:ext cx="6675120" cy="256032"/>
           </a:xfrm>
           <a:prstGeom prst="rect">
@@ -3386,7 +3386,7 @@
         </p:nvSpPr>
         <p:spPr>
           <a:xfrm>
-            <a:off x="7675245" y="4114800"/>
+            <a:off x="7675245" y="4590288"/>
             <a:ext cx="1251585" cy="256032"/>
           </a:xfrm>
           <a:prstGeom prst="roundRect">
@@ -3413,7 +3413,7 @@
         </p:nvSpPr>
         <p:spPr>
           <a:xfrm>
-            <a:off x="731520" y="4498848"/>
+            <a:off x="731520" y="4919472"/>
             <a:ext cx="3840480" cy="365760"/>
           </a:xfrm>
           <a:prstGeom prst="rect">
@@ -3452,7 +3452,7 @@
         </p:nvSpPr>
         <p:spPr>
           <a:xfrm>
-            <a:off x="4754880" y="4553712"/>
+            <a:off x="4754880" y="4974336"/>
             <a:ext cx="6675120" cy="256032"/>
           </a:xfrm>
           <a:prstGeom prst="rect">
@@ -3477,7 +3477,7 @@
         </p:nvSpPr>
         <p:spPr>
           <a:xfrm>
-            <a:off x="8926830" y="4553712"/>
+            <a:off x="8926830" y="4974336"/>
             <a:ext cx="1251585" cy="256032"/>
           </a:xfrm>
           <a:prstGeom prst="roundRect">
@@ -3504,7 +3504,7 @@
         </p:nvSpPr>
         <p:spPr>
           <a:xfrm>
-            <a:off x="731520" y="4937760"/>
+            <a:off x="731520" y="5303520"/>
             <a:ext cx="3840480" cy="365760"/>
           </a:xfrm>
           <a:prstGeom prst="rect">
@@ -3543,7 +3543,7 @@
         </p:nvSpPr>
         <p:spPr>
           <a:xfrm>
-            <a:off x="4754880" y="4992624"/>
+            <a:off x="4754880" y="5358384"/>
             <a:ext cx="6675120" cy="256032"/>
           </a:xfrm>
           <a:prstGeom prst="rect">
@@ -3568,7 +3568,7 @@
         </p:nvSpPr>
         <p:spPr>
           <a:xfrm>
-            <a:off x="10178415" y="4992624"/>
+            <a:off x="10178415" y="5358384"/>
             <a:ext cx="834390" cy="256032"/>
           </a:xfrm>
           <a:prstGeom prst="roundRect">
@@ -3595,7 +3595,7 @@
         </p:nvSpPr>
         <p:spPr>
           <a:xfrm>
-            <a:off x="731520" y="5376672"/>
+            <a:off x="731520" y="5687568"/>
             <a:ext cx="3840480" cy="365760"/>
           </a:xfrm>
           <a:prstGeom prst="rect">
@@ -3634,7 +3634,7 @@
         </p:nvSpPr>
         <p:spPr>
           <a:xfrm>
-            <a:off x="4754880" y="5431536"/>
+            <a:off x="4754880" y="5742432"/>
             <a:ext cx="6675120" cy="256032"/>
           </a:xfrm>
           <a:prstGeom prst="rect">
@@ -3659,7 +3659,7 @@
         </p:nvSpPr>
         <p:spPr>
           <a:xfrm>
-            <a:off x="11012805" y="5431536"/>
+            <a:off x="11012805" y="5742432"/>
             <a:ext cx="417195" cy="256032"/>
           </a:xfrm>
           <a:prstGeom prst="roundRect">
@@ -3686,7 +3686,7 @@
         </p:nvSpPr>
         <p:spPr>
           <a:xfrm>
-            <a:off x="4754880" y="5852160"/>
+            <a:off x="4754880" y="6053328"/>
             <a:ext cx="1097280" cy="274320"/>
           </a:xfrm>
           <a:prstGeom prst="rect">
@@ -3725,7 +3725,7 @@
         </p:nvSpPr>
         <p:spPr>
           <a:xfrm>
-            <a:off x="10332720" y="5852160"/>
+            <a:off x="10332720" y="6053328"/>
             <a:ext cx="1097280" cy="274320"/>
           </a:xfrm>
           <a:prstGeom prst="rect">
@@ -4497,7 +4497,7 @@
                 <a:ea typeface="Calibri" pitchFamily="34" charset="-122"/>
                 <a:cs typeface="Calibri" pitchFamily="34" charset="-120"/>
               </a:rPr>
-              <a:t>Logging samples in when they arrive is the biggest single queue.</a:t>
+              <a:t>Logging samples in on arrival (accessioning) is the biggest single queue.</a:t>
             </a:r>
             <a:endParaRPr lang="en-US" sz="1600" dirty="0"/>
           </a:p>
@@ -9059,7 +9059,7 @@
                 <a:ea typeface="Calibri" pitchFamily="34" charset="-122"/>
                 <a:cs typeface="Calibri" pitchFamily="34" charset="-120"/>
               </a:rPr>
-              <a:t>Each lever removes a queue rather than speeding up a step, so the gains do not depend on staff working faster.</a:t>
+              <a:t>Each lever removes a queue, so the before and after columns show waiting time that disappears.</a:t>
             </a:r>
             <a:endParaRPr lang="en-US" sz="1600" dirty="0"/>
           </a:p>
@@ -9253,7 +9253,7 @@
                 <a:ea typeface="Calibri" pitchFamily="34" charset="-122"/>
                 <a:cs typeface="Calibri" pitchFamily="34" charset="-120"/>
               </a:rPr>
-              <a:t>The money comes back within two months, and every quality measure improves.</a:t>
+              <a:t>The money comes back in 1.4 months, and every quality measure improves.</a:t>
             </a:r>
             <a:endParaRPr lang="en-US" sz="1600" dirty="0"/>
           </a:p>

</xml_diff>

<commit_message>
fix: readable callout label and clearer deck and Pareto copy
Co-Authored-By: Claude Opus 5.5 <noreply@anthropic.com>
</commit_message>
<xml_diff>
--- a/deck/sovereign-health-exec-briefing.pptx
+++ b/deck/sovereign-health-exec-briefing.pptx
@@ -116,21 +116,21 @@
   <p:extLst>
     <p:ext uri="{521415D9-36F7-43E2-AB2F-B90AF26B5E84}">
       <p14:sectionLst xmlns:p14="http://schemas.microsoft.com/office/powerpoint/2010/main">
-        <p14:section name="What?" id="{3ae859fa-88f0-1b5e-0e63-4f9fefe55699}">
+        <p14:section name="What?" id="{fcf33a46-9612-bb30-10bf-bd1f34cca1ae}">
           <p14:sldIdLst>
             <p14:sldId id="256"/>
             <p14:sldId id="257"/>
             <p14:sldId id="258"/>
           </p14:sldIdLst>
         </p14:section>
-        <p14:section name="So What?" id="{d8b120e7-8a46-edbd-8bce-19428de9a015}">
+        <p14:section name="So What?" id="{e815e472-fe43-a8ba-f20a-988f5288dbad}">
           <p14:sldIdLst>
             <p14:sldId id="259"/>
             <p14:sldId id="260"/>
             <p14:sldId id="261"/>
           </p14:sldIdLst>
         </p14:section>
-        <p14:section name="Now What?" id="{ce1888df-d44b-35cb-27ae-412ec9989c87}">
+        <p14:section name="Now What?" id="{867b1654-9dca-be7e-73c7-8487e87e4f84}">
           <p14:sldIdLst>
             <p14:sldId id="262"/>
             <p14:sldId id="263"/>
@@ -9059,7 +9059,7 @@
                 <a:ea typeface="Calibri" pitchFamily="34" charset="-122"/>
                 <a:cs typeface="Calibri" pitchFamily="34" charset="-120"/>
               </a:rPr>
-              <a:t>Each lever removes a queue, so the before and after columns show waiting time that disappears.</a:t>
+              <a:t>Each lever removes a queue, so most of the before and after gap is waiting time that disappears.</a:t>
             </a:r>
             <a:endParaRPr lang="en-US" sz="1600" dirty="0"/>
           </a:p>

</xml_diff>

<commit_message>
fix: final review fixes (contrast token, copy accuracy, callout guard)
Co-Authored-By: Claude Opus 5.5 <noreply@anthropic.com>
</commit_message>
<xml_diff>
--- a/deck/sovereign-health-exec-briefing.pptx
+++ b/deck/sovereign-health-exec-briefing.pptx
@@ -116,21 +116,21 @@
   <p:extLst>
     <p:ext uri="{521415D9-36F7-43E2-AB2F-B90AF26B5E84}">
       <p14:sectionLst xmlns:p14="http://schemas.microsoft.com/office/powerpoint/2010/main">
-        <p14:section name="What?" id="{fcf33a46-9612-bb30-10bf-bd1f34cca1ae}">
+        <p14:section name="What?" id="{77403a7a-5cab-76b4-a754-686c049cc269}">
           <p14:sldIdLst>
             <p14:sldId id="256"/>
             <p14:sldId id="257"/>
             <p14:sldId id="258"/>
           </p14:sldIdLst>
         </p14:section>
-        <p14:section name="So What?" id="{e815e472-fe43-a8ba-f20a-988f5288dbad}">
+        <p14:section name="So What?" id="{9bedcb59-2bba-a02d-ede9-ab81c80493ad}">
           <p14:sldIdLst>
             <p14:sldId id="259"/>
             <p14:sldId id="260"/>
             <p14:sldId id="261"/>
           </p14:sldIdLst>
         </p14:section>
-        <p14:section name="Now What?" id="{867b1654-9dca-be7e-73c7-8487e87e4f84}">
+        <p14:section name="Now What?" id="{9afcad09-3e7b-1683-a52a-68a4ddec861d}">
           <p14:sldIdLst>
             <p14:sldId id="262"/>
             <p14:sldId id="263"/>
@@ -1287,7 +1287,7 @@
           <a:p>
             <a:r>
               <a:rPr lang="en-US" dirty="0"/>
-              <a:t>Talking point: We need two things today: approval for $520K and an executive sponsor. The first results arrive with the central hub and ED rollout in weeks 11 to 13.
+              <a:t>Talking point: We need two things today: approval for $520K and an executive sponsor. The central hub and ED go live in weeks 11 to 13.
 Detail: Ask: approve capital and name an executive sponsor for the central hub and ED deployment in weeks 11 to 13.</a:t>
             </a:r>
             <a:endParaRPr lang="en-US" dirty="0"/>
@@ -4303,7 +4303,7 @@
                 <a:ea typeface="Calibri" pitchFamily="34" charset="-122"/>
                 <a:cs typeface="Calibri" pitchFamily="34" charset="-120"/>
               </a:rPr>
-              <a:t> send 1.2 million lab orders a year through one central lab. The bottleneck is not the analyzer; it is how specimens and data reach it.</a:t>
+              <a:t> send 1.2 million lab orders a year through one central lab. The bottleneck is how specimens and data reach the analyzer.</a:t>
             </a:r>
             <a:endParaRPr lang="en-US" sz="1600" dirty="0"/>
           </a:p>

</xml_diff>